<commit_message>
Update technical presentation reproducibility status
</commit_message>
<xml_diff>
--- a/reports/Franklin_Guillano_DIAL_ALERT_Technical_Presentation.pptx
+++ b/reports/Franklin_Guillano_DIAL_ALERT_Technical_Presentation.pptx
@@ -4394,7 +4394,7 @@
                 <a:ea typeface="Nimbus Sans"/>
                 <a:cs typeface="Nimbus Sans"/>
               </a:rPr>
-              <a:t>Reproduction instructions are provided; full rerun is blocked</a:t>
+              <a:t>End-to-end reproduction successfully completed</a:t>
             </a:r>
           </a:p>
         </p:txBody>
@@ -4452,7 +4452,7 @@
                 <a:ea typeface="Nimbus Sans"/>
                 <a:cs typeface="Nimbus Sans"/>
               </a:rPr>
-              <a:t>Clean environment installed; source acquisition returned HTTP 403</a:t>
+              <a:t>Fresh Python 3.12 reproduction completed on 20 September 2026</a:t>
             </a:r>
           </a:p>
         </p:txBody>
@@ -6190,7 +6190,7 @@
                 <a:ea typeface="Nimbus Sans"/>
                 <a:cs typeface="Nimbus Sans"/>
               </a:rPr>
-              <a:t>Execution record: included-model checks passed; full data-to-training run is blocked.</a:t>
+              <a:t>HEMOBP Version 3 was reacquired and checksum-verified; the dataset was rebuilt, models retrained, outputs regenerated, and 15/15 automated tests passed.</a:t>
             </a:r>
           </a:p>
         </p:txBody>
@@ -7305,7 +7305,7 @@
                 </a:solidFill>
                 <a:latin typeface="Nimbus Sans"/>
               </a:rPr>
-              <a:t>Saved-model inference can run without source data. Full source-to-training reproduction remains blocked by HTTP 403.</a:t>
+              <a:t>Full source-to-training reproduction was completed on 20 September 2026. Results were numerically consistent with the locked reference rather than byte-for-byte identical.</a:t>
             </a:r>
           </a:p>
         </p:txBody>

</xml_diff>